<commit_message>
Minor updates to powerpoint dec.
Signed-off-by: Bruce E. Wilson <bruce@usethedata.net>
</commit_message>
<xml_diff>
--- a/AI Merit Badge slides.pptx
+++ b/AI Merit Badge slides.pptx
@@ -19004,7 +19004,7 @@
                 <a:ea typeface="Arial" pitchFamily="34" charset="-122"/>
                 <a:cs typeface="Arial" pitchFamily="34" charset="-120"/>
               </a:rPr>
-              <a:t>In class: Requirements 1–6</a:t>
+              <a:t>In class: Requirements 1–6 (except 4c)</a:t>
             </a:r>
             <a:endParaRPr lang="en-US" sz="3600" dirty="0"/>
           </a:p>
@@ -19025,7 +19025,7 @@
                 <a:ea typeface="Arial" pitchFamily="34" charset="-122"/>
                 <a:cs typeface="Arial" pitchFamily="34" charset="-120"/>
               </a:rPr>
-              <a:t>On your own: 7 and 8 (if not already done)</a:t>
+              <a:t>On your own: 4c, 7 and 8</a:t>
             </a:r>
             <a:endParaRPr lang="en-US" sz="3600" dirty="0"/>
           </a:p>
@@ -19065,7 +19065,7 @@
                 <a:latin typeface="Arial" pitchFamily="34" charset="0"/>
                 <a:cs typeface="Arial" pitchFamily="34" charset="-120"/>
               </a:rPr>
-              <a:t>Handout with more information at the end of class</a:t>
+              <a:t>&lt;I provided a handout with this info at the end of class&gt;</a:t>
             </a:r>
             <a:endParaRPr lang="en-US" sz="3600" dirty="0"/>
           </a:p>

</xml_diff>